<commit_message>
Bring the deck up to 1.1.0 and fix its punctuation
Slide 10 still claimed 1.0.1. Slide 8 listed three element types when there
are four, so TextElement was missing from the diagram entirely; the row is now
four boxes across, evenly spaced within the title's margins.

The deck was also still full of the middots and em-dashes that were stripped
from the code and docs earlier: 28 runs across slides and speaker notes. Those
are rewritten as prose rather than swapped character for character.
</commit_message>
<xml_diff>
--- a/EZCanvas-Presentation.pptx
+++ b/EZCanvas-Presentation.pptx
@@ -514,7 +514,7 @@
           <a:p>
             <a:r>
               <a:rPr lang="en-US" dirty="0"/>
-              <a:t>Open: EZCanvas is a reusable Android library — a drawing canvas plus a complete, configurable toolbar. The whole pitch: developers keep rebuilding drawing surfaces; this does it once and lets you turn features on or off.</a:t>
+              <a:t>Open: EZCanvas is a reusable Android library: a drawing canvas plus a complete, configurable toolbar. The whole pitch: developers keep rebuilding drawing surfaces; this does it once and lets you turn features on or off.</a:t>
             </a:r>
             <a:endParaRPr lang="en-US" dirty="0"/>
           </a:p>
@@ -690,7 +690,7 @@
           <a:p>
             <a:r>
               <a:rPr lang="en-US" dirty="0"/>
-              <a:t>Standard modern Android stack: single Activity, all Jetpack Compose, no XML. The library itself depends only on Compose — easy to drop into any project.</a:t>
+              <a:t>Standard modern Android stack: single Activity, all Jetpack Compose, no XML. The library itself depends only on Compose, so it is easy to drop into any project.</a:t>
             </a:r>
             <a:endParaRPr lang="en-US" dirty="0"/>
           </a:p>
@@ -778,7 +778,7 @@
           <a:p>
             <a:r>
               <a:rPr lang="en-US" dirty="0"/>
-              <a:t>Honest forward look. These are documented as future work — the v1 scope (everything shown so far) is complete and demoable on its own.</a:t>
+              <a:t>Honest forward look. These are documented as future work. The v1 scope (everything shown so far) is complete and demoable on its own.</a:t>
             </a:r>
             <a:endParaRPr lang="en-US" dirty="0"/>
           </a:p>
@@ -866,7 +866,7 @@
           <a:p>
             <a:r>
               <a:rPr lang="en-US" dirty="0"/>
-              <a:t>Close on the ask: approve the idea. Reiterate it's a genuinely reusable library plus a real demo app, not just a sample — and the roadmap shows it has room to grow.</a:t>
+              <a:t>Close on the ask: approve the idea. Reiterate it's a genuinely reusable library plus a real demo app, not just a sample, and the roadmap shows it has room to grow.</a:t>
             </a:r>
             <a:endParaRPr lang="en-US" dirty="0"/>
           </a:p>
@@ -1042,7 +1042,7 @@
           <a:p>
             <a:r>
               <a:rPr lang="en-US" dirty="0"/>
-              <a:t>The solution in one line: a canvas composable and a toolbar composable that share one state holder. The developer decides which controls the toolbar exposes — that's the whole product idea.</a:t>
+              <a:t>The solution in one line: a canvas composable and a toolbar composable that share one state holder. The developer decides which controls the toolbar exposes. That's the whole product idea.</a:t>
             </a:r>
             <a:endParaRPr lang="en-US" dirty="0"/>
           </a:p>
@@ -1130,7 +1130,7 @@
           <a:p>
             <a:r>
               <a:rPr lang="en-US" dirty="0"/>
-              <a:t>The key differentiator. Most drawing libraries hand you a fixed UI. Here the same EzToolbar is a two-button signature pad or a full studio — you just change what's enabled. The configuration is the point.</a:t>
+              <a:t>The key differentiator. Most drawing libraries hand you a fixed UI. Here the same EzToolbar is a two-button signature pad or a full studio. You just change what's enabled. The configuration is the point.</a:t>
             </a:r>
             <a:endParaRPr lang="en-US" dirty="0"/>
           </a:p>
@@ -1218,7 +1218,7 @@
           <a:p>
             <a:r>
               <a:rPr lang="en-US" dirty="0"/>
-              <a:t>Walk the grid quickly. Emphasize the paint bucket (a real scanline flood fill) and export — these are the hard parts the library owns so the developer doesn't.</a:t>
+              <a:t>Walk the grid quickly. Emphasize the paint bucket (a real scanline flood fill) and export. These are the hard parts the library owns so the developer doesn't.</a:t>
             </a:r>
             <a:endParaRPr lang="en-US" dirty="0"/>
           </a:p>
@@ -1306,7 +1306,7 @@
           <a:p>
             <a:r>
               <a:rPr lang="en-US" dirty="0"/>
-              <a:t>This is the entire integration. A state holder, a canvas, a toolbar. Pause here — this is the 'look how easy' moment. Everything else is just choosing which features to enable.</a:t>
+              <a:t>This is the entire integration. A state holder, a canvas, a toolbar. Pause here. This is the 'look how easy' moment. Everything else is just choosing which features to enable.</a:t>
             </a:r>
             <a:endParaRPr lang="en-US" dirty="0"/>
           </a:p>
@@ -1394,7 +1394,7 @@
           <a:p>
             <a:r>
               <a:rPr lang="en-US" dirty="0"/>
-              <a:t>The demo app ships these seven. Same library, seven deliberately different feature sets — each is about ten readable lines. This proves the configurability claim in real code.</a:t>
+              <a:t>The demo app ships these seven. Same library, seven deliberately different feature sets. Each is about ten readable lines. This proves the configurability claim in real code.</a:t>
             </a:r>
             <a:endParaRPr lang="en-US" dirty="0"/>
           </a:p>
@@ -1482,7 +1482,7 @@
           <a:p>
             <a:r>
               <a:rPr lang="en-US" dirty="0"/>
-              <a:t>Every drawn item is one of three serializable elements in a single list. That one model is why undo/redo, export and rotation all just work. And the app holds zero engine code — proven by a grep audit.</a:t>
+              <a:t>Every drawn item is one of four serializable elements in a single list. That one model is why undo/redo, export and rotation all just work. And the app holds zero engine code, proven by a grep audit.</a:t>
             </a:r>
             <a:endParaRPr lang="en-US" dirty="0"/>
           </a:p>
@@ -2015,7 +2015,7 @@
                 <a:ea typeface="Calibri" pitchFamily="34" charset="-122"/>
                 <a:cs typeface="Calibri" pitchFamily="34" charset="-120"/>
               </a:rPr>
-              <a:t>A configurable, exportable drawing-canvas library for Android — built entirely in Jetpack Compose.</a:t>
+              <a:t>A configurable, exportable drawing-canvas library for Android, built entirely in Jetpack Compose.</a:t>
             </a:r>
             <a:endParaRPr lang="en-US" sz="1800" dirty="0"/>
           </a:p>
@@ -2471,7 +2471,7 @@
                 <a:ea typeface="Calibri" pitchFamily="34" charset="-122"/>
                 <a:cs typeface="Calibri" pitchFamily="34" charset="-120"/>
               </a:rPr>
-              <a:t>1.0.1</a:t>
+              <a:t>1.1.0</a:t>
             </a:r>
             <a:endParaRPr lang="en-US" sz="4400" dirty="0"/>
           </a:p>
@@ -3487,7 +3487,7 @@
                 <a:ea typeface="Calibri" pitchFamily="34" charset="-122"/>
                 <a:cs typeface="Calibri" pitchFamily="34" charset="-120"/>
               </a:rPr>
-              <a:t>One Activity · all Compose · library depends only on Compose — no DI, no networking.</a:t>
+              <a:t>One Activity, all Compose. The library depends only on Compose, with no DI and no networking.</a:t>
             </a:r>
             <a:endParaRPr lang="en-US" sz="1300" dirty="0"/>
           </a:p>
@@ -4366,7 +4366,7 @@
                 <a:ea typeface="Calibri" pitchFamily="34" charset="-122"/>
                 <a:cs typeface="Calibri" pitchFamily="34" charset="-120"/>
               </a:rPr>
-              <a:t>EZCanvas — the drawing surface Android keeps making you rebuild, done once.</a:t>
+              <a:t>EZCanvas: the drawing surface Android keeps making you rebuild, done once.</a:t>
             </a:r>
             <a:endParaRPr lang="en-US" sz="1600" dirty="0"/>
           </a:p>
@@ -5060,7 +5060,7 @@
                 <a:ea typeface="Calibri" pitchFamily="34" charset="-122"/>
                 <a:cs typeface="Calibri" pitchFamily="34" charset="-120"/>
               </a:rPr>
-              <a:t>smooth touch handling · undo/redo · brushes · flood fill · bitmap export · surviving rotation</a:t>
+              <a:t>smooth touch handling, undo/redo, brushes, flood fill, bitmap export, surviving rotation</a:t>
             </a:r>
             <a:endParaRPr lang="en-US" sz="1400" dirty="0"/>
           </a:p>
@@ -5232,7 +5232,7 @@
                 <a:ea typeface="Calibri" pitchFamily="34" charset="-122"/>
                 <a:cs typeface="Calibri" pitchFamily="34" charset="-120"/>
               </a:rPr>
-              <a:t>The drawing surface — touch handling, brushes, shapes, fill, export.</a:t>
+              <a:t>The drawing surface: touch handling, brushes, shapes, fill, export.</a:t>
             </a:r>
             <a:endParaRPr lang="en-US" sz="1600" dirty="0"/>
           </a:p>
@@ -6396,7 +6396,7 @@
                 <a:ea typeface="Calibri" pitchFamily="34" charset="-122"/>
                 <a:cs typeface="Calibri" pitchFamily="34" charset="-120"/>
               </a:rPr>
-              <a:t>Pen · marker · neon · calligraphy</a:t>
+              <a:t>Pen, marker, neon, calligraphy</a:t>
             </a:r>
             <a:endParaRPr lang="en-US" sz="1000" dirty="0"/>
           </a:p>
@@ -6636,7 +6636,7 @@
                 <a:ea typeface="Calibri" pitchFamily="34" charset="-122"/>
                 <a:cs typeface="Calibri" pitchFamily="34" charset="-120"/>
               </a:rPr>
-              <a:t>Line · square · circle (1:1)</a:t>
+              <a:t>Line, square, circle (1:1)</a:t>
             </a:r>
             <a:endParaRPr lang="en-US" sz="1000" dirty="0"/>
           </a:p>
@@ -6756,7 +6756,7 @@
                 <a:ea typeface="Calibri" pitchFamily="34" charset="-122"/>
                 <a:cs typeface="Calibri" pitchFamily="34" charset="-120"/>
               </a:rPr>
-              <a:t>Solid · dotted · dashed · dash-dot</a:t>
+              <a:t>Solid, dotted, dashed, dash-dot</a:t>
             </a:r>
             <a:endParaRPr lang="en-US" sz="1000" dirty="0"/>
           </a:p>
@@ -6996,7 +6996,7 @@
                 <a:ea typeface="Calibri" pitchFamily="34" charset="-122"/>
                 <a:cs typeface="Calibri" pitchFamily="34" charset="-120"/>
               </a:rPr>
-              <a:t>Color · patterns · your photo</a:t>
+              <a:t>Color, patterns, your photo</a:t>
             </a:r>
             <a:endParaRPr lang="en-US" sz="1000" dirty="0"/>
           </a:p>
@@ -7116,7 +7116,7 @@
                 <a:ea typeface="Calibri" pitchFamily="34" charset="-122"/>
                 <a:cs typeface="Calibri" pitchFamily="34" charset="-120"/>
               </a:rPr>
-              <a:t>Undo · redo · clear</a:t>
+              <a:t>Undo, redo, clear</a:t>
             </a:r>
             <a:endParaRPr lang="en-US" sz="1000" dirty="0"/>
           </a:p>
@@ -7588,7 +7588,7 @@
                 <a:ea typeface="Calibri" pitchFamily="34" charset="-122"/>
                 <a:cs typeface="Calibri" pitchFamily="34" charset="-120"/>
               </a:rPr>
-              <a:t>Enable the tools and controls you want — the toolbar renders the rest.</a:t>
+              <a:t>Enable the tools and controls you want, and the toolbar renders the rest.</a:t>
             </a:r>
             <a:endParaRPr lang="en-US" sz="1400" dirty="0"/>
           </a:p>
@@ -7850,7 +7850,7 @@
                 <a:ea typeface="Calibri" pitchFamily="34" charset="-122"/>
                 <a:cs typeface="Calibri" pitchFamily="34" charset="-120"/>
               </a:rPr>
-              <a:t>Pen · export</a:t>
+              <a:t>Pen, export</a:t>
             </a:r>
             <a:endParaRPr lang="en-US" sz="1000" dirty="0"/>
           </a:p>
@@ -8002,7 +8002,7 @@
                 <a:ea typeface="Calibri" pitchFamily="34" charset="-122"/>
                 <a:cs typeface="Calibri" pitchFamily="34" charset="-120"/>
               </a:rPr>
-              <a:t>Fat brushes · fill</a:t>
+              <a:t>Fat brushes, fill</a:t>
             </a:r>
             <a:endParaRPr lang="en-US" sz="1000" dirty="0"/>
           </a:p>
@@ -8458,7 +8458,7 @@
                 <a:ea typeface="Calibri" pitchFamily="34" charset="-122"/>
                 <a:cs typeface="Calibri" pitchFamily="34" charset="-120"/>
               </a:rPr>
-              <a:t>Shapes · grid</a:t>
+              <a:t>Shapes, grid</a:t>
             </a:r>
             <a:endParaRPr lang="en-US" sz="1000" dirty="0"/>
           </a:p>
@@ -8610,7 +8610,7 @@
                 <a:ea typeface="Calibri" pitchFamily="34" charset="-122"/>
                 <a:cs typeface="Calibri" pitchFamily="34" charset="-120"/>
               </a:rPr>
-              <a:t>One pen · fast</a:t>
+              <a:t>One pen, fast</a:t>
             </a:r>
             <a:endParaRPr lang="en-US" sz="1000" dirty="0"/>
           </a:p>
@@ -9038,7 +9038,7 @@
         </p:nvSpPr>
         <p:spPr>
           <a:xfrm>
-            <a:off x="914400" y="2697480"/>
+            <a:off x="548640" y="2697480"/>
             <a:ext cx="1828800" cy="548640"/>
           </a:xfrm>
           <a:prstGeom prst="rect">
@@ -9122,7 +9122,7 @@
         </p:nvSpPr>
         <p:spPr>
           <a:xfrm>
-            <a:off x="3657600" y="2697480"/>
+            <a:off x="2621280" y="2697480"/>
             <a:ext cx="1828800" cy="548640"/>
           </a:xfrm>
           <a:prstGeom prst="rect">
@@ -9200,13 +9200,52 @@
       </p:sp>
       <p:sp>
         <p:nvSpPr>
+          <p:cNvPr id="22" name="TextElement box"/>
+          <p:cNvSpPr/>
+          <p:nvPr/>
+        </p:nvSpPr>
+        <p:spPr>
+          <a:xfrm>
+            <a:off x="4693920" y="2697480"/>
+            <a:ext cx="1828800" cy="548640"/>
+          </a:xfrm>
+          <a:prstGeom prst="rect">
+            <a:avLst/>
+          </a:prstGeom>
+          <a:noFill/>
+          <a:ln/>
+        </p:spPr>
+        <p:txBody>
+          <a:bodyPr wrap="square" lIns="0" tIns="0" rIns="0" bIns="0" rtlCol="0" anchor="ctr"/>
+          <a:lstStyle/>
+          <a:p>
+            <a:pPr algn="ctr" indent="0" marL="0">
+              <a:buNone/>
+            </a:pPr>
+            <a:r>
+              <a:rPr lang="en-US" sz="1200" b="1" dirty="0">
+                <a:solidFill>
+                  <a:srgbClr val="0C0C0E"/>
+                </a:solidFill>
+                <a:latin typeface="Calibri" pitchFamily="34" charset="0"/>
+                <a:ea typeface="Calibri" pitchFamily="34" charset="-122"/>
+                <a:cs typeface="Calibri" pitchFamily="34" charset="-120"/>
+              </a:rPr>
+              <a:t>TextElement</a:t>
+            </a:r>
+            <a:endParaRPr lang="en-US" sz="1200" dirty="0"/>
+          </a:p>
+        </p:txBody>
+      </p:sp>
+      <p:sp>
+        <p:nvSpPr>
           <p:cNvPr id="16" name="Text 14"/>
           <p:cNvSpPr/>
           <p:nvPr/>
         </p:nvSpPr>
         <p:spPr>
           <a:xfrm>
-            <a:off x="6400800" y="2697480"/>
+            <a:off x="6766560" y="2697480"/>
             <a:ext cx="1828800" cy="548640"/>
           </a:xfrm>
           <a:prstGeom prst="rect">
@@ -9270,7 +9309,7 @@
                 <a:ea typeface="Calibri" pitchFamily="34" charset="-122"/>
                 <a:cs typeface="Calibri" pitchFamily="34" charset="-120"/>
               </a:rPr>
-              <a:t>One ordered list →  undo / redo  ·  export  ·  rotation restore</a:t>
+              <a:t>One ordered list →  undo / redo, export, rotation restore</a:t>
             </a:r>
             <a:endParaRPr lang="en-US" sz="1400" dirty="0"/>
           </a:p>
@@ -9331,7 +9370,7 @@
                 <a:ea typeface="Calibri" pitchFamily="34" charset="-122"/>
                 <a:cs typeface="Calibri" pitchFamily="34" charset="-120"/>
               </a:rPr>
-              <a:t>:ezcanvas  —  engine + toolbar</a:t>
+              <a:t>:ezcanvas  =  engine + toolbar</a:t>
             </a:r>
             <a:endParaRPr lang="en-US" sz="1200" dirty="0"/>
           </a:p>
@@ -9397,7 +9436,7 @@
                 <a:ea typeface="Calibri" pitchFamily="34" charset="-122"/>
                 <a:cs typeface="Calibri" pitchFamily="34" charset="-120"/>
               </a:rPr>
-              <a:t>:app  —  consumes public API only</a:t>
+              <a:t>:app  =  consumes public API only</a:t>
             </a:r>
             <a:endParaRPr lang="en-US" sz="1200" dirty="0"/>
           </a:p>

</xml_diff>